<commit_message>
04-16-2026 - Finished module 4
</commit_message>
<xml_diff>
--- a/lectures/module_03/module_03_both.pptx
+++ b/lectures/module_03/module_03_both.pptx
@@ -134,15 +134,15 @@
 </file>
 
 <file path=ppt/diagrams/colors1.xml><?xml version="1.0" encoding="utf-8"?>
-<dgm:colorsDef xmlns:dgm="http://schemas.openxmlformats.org/drawingml/2006/diagram" xmlns:a="http://schemas.openxmlformats.org/drawingml/2006/main" uniqueId="urn:microsoft.com/office/officeart/2005/8/colors/colorful1">
+<dgm:colorsDef xmlns:dgm="http://schemas.openxmlformats.org/drawingml/2006/diagram" xmlns:a="http://schemas.openxmlformats.org/drawingml/2006/main" uniqueId="urn:microsoft.com/office/officeart/2005/8/colors/accent2_2">
   <dgm:title val=""/>
   <dgm:desc val=""/>
   <dgm:catLst>
-    <dgm:cat type="colorful" pri="10100"/>
+    <dgm:cat type="accent2" pri="11200"/>
   </dgm:catLst>
   <dgm:styleLbl name="node0">
     <dgm:fillClrLst meth="repeat">
-      <a:schemeClr val="accent1"/>
+      <a:schemeClr val="accent2"/>
     </dgm:fillClrLst>
     <dgm:linClrLst meth="repeat">
       <a:schemeClr val="lt1"/>
@@ -155,10 +155,6 @@
   <dgm:styleLbl name="node1">
     <dgm:fillClrLst meth="repeat">
       <a:schemeClr val="accent2"/>
-      <a:schemeClr val="accent3"/>
-      <a:schemeClr val="accent4"/>
-      <a:schemeClr val="accent5"/>
-      <a:schemeClr val="accent6"/>
     </dgm:fillClrLst>
     <dgm:linClrLst meth="repeat">
       <a:schemeClr val="lt1"/>
@@ -171,17 +167,9 @@
   <dgm:styleLbl name="alignNode1">
     <dgm:fillClrLst meth="repeat">
       <a:schemeClr val="accent2"/>
-      <a:schemeClr val="accent3"/>
-      <a:schemeClr val="accent4"/>
-      <a:schemeClr val="accent5"/>
-      <a:schemeClr val="accent6"/>
     </dgm:fillClrLst>
     <dgm:linClrLst meth="repeat">
       <a:schemeClr val="accent2"/>
-      <a:schemeClr val="accent3"/>
-      <a:schemeClr val="accent4"/>
-      <a:schemeClr val="accent5"/>
-      <a:schemeClr val="accent6"/>
     </dgm:linClrLst>
     <dgm:effectClrLst/>
     <dgm:txLinClrLst/>
@@ -191,10 +179,6 @@
   <dgm:styleLbl name="lnNode1">
     <dgm:fillClrLst meth="repeat">
       <a:schemeClr val="accent2"/>
-      <a:schemeClr val="accent3"/>
-      <a:schemeClr val="accent4"/>
-      <a:schemeClr val="accent5"/>
-      <a:schemeClr val="accent6"/>
     </dgm:fillClrLst>
     <dgm:linClrLst meth="repeat">
       <a:schemeClr val="lt1"/>
@@ -209,18 +193,6 @@
       <a:schemeClr val="accent2">
         <a:alpha val="50000"/>
       </a:schemeClr>
-      <a:schemeClr val="accent3">
-        <a:alpha val="50000"/>
-      </a:schemeClr>
-      <a:schemeClr val="accent4">
-        <a:alpha val="50000"/>
-      </a:schemeClr>
-      <a:schemeClr val="accent5">
-        <a:alpha val="50000"/>
-      </a:schemeClr>
-      <a:schemeClr val="accent6">
-        <a:alpha val="50000"/>
-      </a:schemeClr>
     </dgm:fillClrLst>
     <dgm:linClrLst meth="repeat">
       <a:schemeClr val="lt1"/>
@@ -231,7 +203,7 @@
     <dgm:txEffectClrLst/>
   </dgm:styleLbl>
   <dgm:styleLbl name="node2">
-    <dgm:fillClrLst>
+    <dgm:fillClrLst meth="repeat">
       <a:schemeClr val="accent2"/>
     </dgm:fillClrLst>
     <dgm:linClrLst meth="repeat">
@@ -243,8 +215,8 @@
     <dgm:txEffectClrLst/>
   </dgm:styleLbl>
   <dgm:styleLbl name="node3">
-    <dgm:fillClrLst>
-      <a:schemeClr val="accent3"/>
+    <dgm:fillClrLst meth="repeat">
+      <a:schemeClr val="accent2"/>
     </dgm:fillClrLst>
     <dgm:linClrLst meth="repeat">
       <a:schemeClr val="lt1"/>
@@ -255,8 +227,8 @@
     <dgm:txEffectClrLst/>
   </dgm:styleLbl>
   <dgm:styleLbl name="node4">
-    <dgm:fillClrLst>
-      <a:schemeClr val="accent4"/>
+    <dgm:fillClrLst meth="repeat">
+      <a:schemeClr val="accent2"/>
     </dgm:fillClrLst>
     <dgm:linClrLst meth="repeat">
       <a:schemeClr val="lt1"/>
@@ -271,16 +243,20 @@
       <a:schemeClr val="accent2">
         <a:tint val="50000"/>
       </a:schemeClr>
-      <a:schemeClr val="accent3">
-        <a:tint val="50000"/>
-      </a:schemeClr>
-      <a:schemeClr val="accent4">
-        <a:tint val="50000"/>
-      </a:schemeClr>
-      <a:schemeClr val="accent5">
-        <a:tint val="50000"/>
-      </a:schemeClr>
-      <a:schemeClr val="accent6">
+    </dgm:fillClrLst>
+    <dgm:linClrLst meth="repeat">
+      <a:schemeClr val="lt1"/>
+    </dgm:linClrLst>
+    <dgm:effectClrLst/>
+    <dgm:txLinClrLst/>
+    <dgm:txFillClrLst meth="repeat">
+      <a:schemeClr val="lt1"/>
+    </dgm:txFillClrLst>
+    <dgm:txEffectClrLst/>
+  </dgm:styleLbl>
+  <dgm:styleLbl name="alignImgPlace1">
+    <dgm:fillClrLst meth="repeat">
+      <a:schemeClr val="accent2">
         <a:tint val="50000"/>
       </a:schemeClr>
     </dgm:fillClrLst>
@@ -294,32 +270,10 @@
     </dgm:txFillClrLst>
     <dgm:txEffectClrLst/>
   </dgm:styleLbl>
-  <dgm:styleLbl name="alignImgPlace1">
-    <dgm:fillClrLst>
-      <a:schemeClr val="accent1">
+  <dgm:styleLbl name="bgImgPlace1">
+    <dgm:fillClrLst meth="repeat">
+      <a:schemeClr val="accent2">
         <a:tint val="50000"/>
-      </a:schemeClr>
-      <a:schemeClr val="accent2">
-        <a:tint val="20000"/>
-      </a:schemeClr>
-    </dgm:fillClrLst>
-    <dgm:linClrLst meth="repeat">
-      <a:schemeClr val="lt1"/>
-    </dgm:linClrLst>
-    <dgm:effectClrLst/>
-    <dgm:txLinClrLst/>
-    <dgm:txFillClrLst meth="repeat">
-      <a:schemeClr val="lt1"/>
-    </dgm:txFillClrLst>
-    <dgm:txEffectClrLst/>
-  </dgm:styleLbl>
-  <dgm:styleLbl name="bgImgPlace1">
-    <dgm:fillClrLst>
-      <a:schemeClr val="accent1">
-        <a:tint val="50000"/>
-      </a:schemeClr>
-      <a:schemeClr val="accent2">
-        <a:tint val="20000"/>
       </a:schemeClr>
     </dgm:fillClrLst>
     <dgm:linClrLst meth="repeat">
@@ -334,14 +288,14 @@
   </dgm:styleLbl>
   <dgm:styleLbl name="sibTrans2D1">
     <dgm:fillClrLst meth="repeat">
-      <a:schemeClr val="accent2"/>
-      <a:schemeClr val="accent3"/>
-      <a:schemeClr val="accent4"/>
-      <a:schemeClr val="accent5"/>
-      <a:schemeClr val="accent6"/>
+      <a:schemeClr val="accent2">
+        <a:tint val="60000"/>
+      </a:schemeClr>
     </dgm:fillClrLst>
-    <dgm:linClrLst meth="cycle">
-      <a:schemeClr val="lt1"/>
+    <dgm:linClrLst meth="repeat">
+      <a:schemeClr val="accent2">
+        <a:tint val="60000"/>
+      </a:schemeClr>
     </dgm:linClrLst>
     <dgm:effectClrLst/>
     <dgm:txLinClrLst/>
@@ -350,54 +304,42 @@
   </dgm:styleLbl>
   <dgm:styleLbl name="fgSibTrans2D1">
     <dgm:fillClrLst meth="repeat">
-      <a:schemeClr val="accent2"/>
-      <a:schemeClr val="accent3"/>
-      <a:schemeClr val="accent4"/>
-      <a:schemeClr val="accent5"/>
-      <a:schemeClr val="accent6"/>
+      <a:schemeClr val="accent2">
+        <a:tint val="60000"/>
+      </a:schemeClr>
     </dgm:fillClrLst>
-    <dgm:linClrLst meth="cycle">
-      <a:schemeClr val="lt1"/>
+    <dgm:linClrLst meth="repeat">
+      <a:schemeClr val="accent2">
+        <a:tint val="60000"/>
+      </a:schemeClr>
     </dgm:linClrLst>
     <dgm:effectClrLst/>
     <dgm:txLinClrLst/>
-    <dgm:txFillClrLst meth="repeat">
-      <a:schemeClr val="lt1"/>
-    </dgm:txFillClrLst>
+    <dgm:txFillClrLst/>
     <dgm:txEffectClrLst/>
   </dgm:styleLbl>
   <dgm:styleLbl name="bgSibTrans2D1">
     <dgm:fillClrLst meth="repeat">
-      <a:schemeClr val="accent2"/>
-      <a:schemeClr val="accent3"/>
-      <a:schemeClr val="accent4"/>
-      <a:schemeClr val="accent5"/>
-      <a:schemeClr val="accent6"/>
+      <a:schemeClr val="accent2">
+        <a:tint val="60000"/>
+      </a:schemeClr>
     </dgm:fillClrLst>
-    <dgm:linClrLst meth="cycle">
-      <a:schemeClr val="lt1"/>
+    <dgm:linClrLst meth="repeat">
+      <a:schemeClr val="accent2">
+        <a:tint val="60000"/>
+      </a:schemeClr>
     </dgm:linClrLst>
     <dgm:effectClrLst/>
     <dgm:txLinClrLst/>
-    <dgm:txFillClrLst meth="repeat">
-      <a:schemeClr val="lt1"/>
-    </dgm:txFillClrLst>
+    <dgm:txFillClrLst/>
     <dgm:txEffectClrLst/>
   </dgm:styleLbl>
   <dgm:styleLbl name="sibTrans1D1">
     <dgm:fillClrLst meth="repeat">
       <a:schemeClr val="accent2"/>
-      <a:schemeClr val="accent3"/>
-      <a:schemeClr val="accent4"/>
-      <a:schemeClr val="accent5"/>
-      <a:schemeClr val="accent6"/>
     </dgm:fillClrLst>
     <dgm:linClrLst meth="repeat">
       <a:schemeClr val="accent2"/>
-      <a:schemeClr val="accent3"/>
-      <a:schemeClr val="accent4"/>
-      <a:schemeClr val="accent5"/>
-      <a:schemeClr val="accent6"/>
     </dgm:linClrLst>
     <dgm:effectClrLst/>
     <dgm:txLinClrLst/>
@@ -424,7 +366,7 @@
   </dgm:styleLbl>
   <dgm:styleLbl name="asst0">
     <dgm:fillClrLst meth="repeat">
-      <a:schemeClr val="accent1"/>
+      <a:schemeClr val="accent2"/>
     </dgm:fillClrLst>
     <dgm:linClrLst meth="repeat">
       <a:schemeClr val="lt1"/>
@@ -447,8 +389,8 @@
     <dgm:txEffectClrLst/>
   </dgm:styleLbl>
   <dgm:styleLbl name="asst2">
-    <dgm:fillClrLst>
-      <a:schemeClr val="accent3"/>
+    <dgm:fillClrLst meth="repeat">
+      <a:schemeClr val="accent2"/>
     </dgm:fillClrLst>
     <dgm:linClrLst meth="repeat">
       <a:schemeClr val="lt1"/>
@@ -459,8 +401,8 @@
     <dgm:txEffectClrLst/>
   </dgm:styleLbl>
   <dgm:styleLbl name="asst3">
-    <dgm:fillClrLst>
-      <a:schemeClr val="accent4"/>
+    <dgm:fillClrLst meth="repeat">
+      <a:schemeClr val="accent2"/>
     </dgm:fillClrLst>
     <dgm:linClrLst meth="repeat">
       <a:schemeClr val="lt1"/>
@@ -471,8 +413,8 @@
     <dgm:txEffectClrLst/>
   </dgm:styleLbl>
   <dgm:styleLbl name="asst4">
-    <dgm:fillClrLst>
-      <a:schemeClr val="accent5"/>
+    <dgm:fillClrLst meth="repeat">
+      <a:schemeClr val="accent2"/>
     </dgm:fillClrLst>
     <dgm:linClrLst meth="repeat">
       <a:schemeClr val="lt1"/>
@@ -484,10 +426,14 @@
   </dgm:styleLbl>
   <dgm:styleLbl name="parChTrans2D1">
     <dgm:fillClrLst meth="repeat">
-      <a:schemeClr val="accent2"/>
+      <a:schemeClr val="accent2">
+        <a:tint val="60000"/>
+      </a:schemeClr>
     </dgm:fillClrLst>
     <dgm:linClrLst meth="repeat">
-      <a:schemeClr val="lt1"/>
+      <a:schemeClr val="accent2">
+        <a:tint val="60000"/>
+      </a:schemeClr>
     </dgm:linClrLst>
     <dgm:effectClrLst/>
     <dgm:txLinClrLst/>
@@ -498,34 +444,38 @@
   </dgm:styleLbl>
   <dgm:styleLbl name="parChTrans2D2">
     <dgm:fillClrLst meth="repeat">
-      <a:schemeClr val="accent3"/>
+      <a:schemeClr val="accent2"/>
     </dgm:fillClrLst>
     <dgm:linClrLst meth="repeat">
-      <a:schemeClr val="lt1"/>
+      <a:schemeClr val="accent2"/>
     </dgm:linClrLst>
     <dgm:effectClrLst/>
     <dgm:txLinClrLst/>
-    <dgm:txFillClrLst/>
+    <dgm:txFillClrLst meth="repeat">
+      <a:schemeClr val="lt1"/>
+    </dgm:txFillClrLst>
     <dgm:txEffectClrLst/>
   </dgm:styleLbl>
   <dgm:styleLbl name="parChTrans2D3">
     <dgm:fillClrLst meth="repeat">
-      <a:schemeClr val="accent4"/>
+      <a:schemeClr val="accent2"/>
     </dgm:fillClrLst>
     <dgm:linClrLst meth="repeat">
-      <a:schemeClr val="lt1"/>
+      <a:schemeClr val="accent2"/>
     </dgm:linClrLst>
     <dgm:effectClrLst/>
     <dgm:txLinClrLst/>
-    <dgm:txFillClrLst/>
+    <dgm:txFillClrLst meth="repeat">
+      <a:schemeClr val="lt1"/>
+    </dgm:txFillClrLst>
     <dgm:txEffectClrLst/>
   </dgm:styleLbl>
   <dgm:styleLbl name="parChTrans2D4">
     <dgm:fillClrLst meth="repeat">
-      <a:schemeClr val="accent5"/>
+      <a:schemeClr val="accent2"/>
     </dgm:fillClrLst>
     <dgm:linClrLst meth="repeat">
-      <a:schemeClr val="lt1"/>
+      <a:schemeClr val="accent2"/>
     </dgm:linClrLst>
     <dgm:effectClrLst/>
     <dgm:txLinClrLst/>
@@ -539,7 +489,9 @@
       <a:schemeClr val="accent2"/>
     </dgm:fillClrLst>
     <dgm:linClrLst meth="repeat">
-      <a:schemeClr val="accent1"/>
+      <a:schemeClr val="accent2">
+        <a:shade val="60000"/>
+      </a:schemeClr>
     </dgm:linClrLst>
     <dgm:effectClrLst/>
     <dgm:txLinClrLst/>
@@ -550,12 +502,12 @@
   </dgm:styleLbl>
   <dgm:styleLbl name="parChTrans1D2">
     <dgm:fillClrLst meth="repeat">
-      <a:schemeClr val="accent3">
-        <a:tint val="90000"/>
-      </a:schemeClr>
+      <a:schemeClr val="accent2"/>
     </dgm:fillClrLst>
     <dgm:linClrLst meth="repeat">
-      <a:schemeClr val="accent2"/>
+      <a:schemeClr val="accent2">
+        <a:shade val="60000"/>
+      </a:schemeClr>
     </dgm:linClrLst>
     <dgm:effectClrLst/>
     <dgm:txLinClrLst/>
@@ -566,12 +518,12 @@
   </dgm:styleLbl>
   <dgm:styleLbl name="parChTrans1D3">
     <dgm:fillClrLst meth="repeat">
-      <a:schemeClr val="accent4">
-        <a:tint val="70000"/>
-      </a:schemeClr>
+      <a:schemeClr val="accent2"/>
     </dgm:fillClrLst>
     <dgm:linClrLst meth="repeat">
-      <a:schemeClr val="accent3"/>
+      <a:schemeClr val="accent2">
+        <a:shade val="80000"/>
+      </a:schemeClr>
     </dgm:linClrLst>
     <dgm:effectClrLst/>
     <dgm:txLinClrLst/>
@@ -582,12 +534,12 @@
   </dgm:styleLbl>
   <dgm:styleLbl name="parChTrans1D4">
     <dgm:fillClrLst meth="repeat">
-      <a:schemeClr val="accent5">
-        <a:tint val="50000"/>
-      </a:schemeClr>
+      <a:schemeClr val="accent2"/>
     </dgm:fillClrLst>
     <dgm:linClrLst meth="repeat">
-      <a:schemeClr val="accent4"/>
+      <a:schemeClr val="accent2">
+        <a:shade val="80000"/>
+      </a:schemeClr>
     </dgm:linClrLst>
     <dgm:effectClrLst/>
     <dgm:txLinClrLst/>
@@ -604,10 +556,6 @@
     </dgm:fillClrLst>
     <dgm:linClrLst meth="repeat">
       <a:schemeClr val="accent2"/>
-      <a:schemeClr val="accent3"/>
-      <a:schemeClr val="accent4"/>
-      <a:schemeClr val="accent5"/>
-      <a:schemeClr val="accent6"/>
     </dgm:linClrLst>
     <dgm:effectClrLst/>
     <dgm:txLinClrLst/>
@@ -624,10 +572,6 @@
     </dgm:fillClrLst>
     <dgm:linClrLst meth="repeat">
       <a:schemeClr val="accent2"/>
-      <a:schemeClr val="accent3"/>
-      <a:schemeClr val="accent4"/>
-      <a:schemeClr val="accent5"/>
-      <a:schemeClr val="accent6"/>
     </dgm:linClrLst>
     <dgm:effectClrLst/>
     <dgm:txLinClrLst/>
@@ -644,10 +588,6 @@
     </dgm:fillClrLst>
     <dgm:linClrLst meth="repeat">
       <a:schemeClr val="accent2"/>
-      <a:schemeClr val="accent3"/>
-      <a:schemeClr val="accent4"/>
-      <a:schemeClr val="accent5"/>
-      <a:schemeClr val="accent6"/>
     </dgm:linClrLst>
     <dgm:effectClrLst/>
     <dgm:txLinClrLst/>
@@ -663,7 +603,7 @@
       </a:schemeClr>
     </dgm:fillClrLst>
     <dgm:linClrLst meth="repeat">
-      <a:schemeClr val="accent1"/>
+      <a:schemeClr val="accent2"/>
     </dgm:linClrLst>
     <dgm:effectClrLst/>
     <dgm:txLinClrLst/>
@@ -680,10 +620,6 @@
     </dgm:fillClrLst>
     <dgm:linClrLst meth="repeat">
       <a:schemeClr val="accent2"/>
-      <a:schemeClr val="accent3"/>
-      <a:schemeClr val="accent4"/>
-      <a:schemeClr val="accent5"/>
-      <a:schemeClr val="accent6"/>
     </dgm:linClrLst>
     <dgm:effectClrLst/>
     <dgm:txLinClrLst/>
@@ -698,10 +634,6 @@
     </dgm:fillClrLst>
     <dgm:linClrLst meth="repeat">
       <a:schemeClr val="accent2"/>
-      <a:schemeClr val="accent3"/>
-      <a:schemeClr val="accent4"/>
-      <a:schemeClr val="accent5"/>
-      <a:schemeClr val="accent6"/>
     </dgm:linClrLst>
     <dgm:effectClrLst/>
     <dgm:txLinClrLst/>
@@ -716,10 +648,6 @@
     </dgm:fillClrLst>
     <dgm:linClrLst meth="repeat">
       <a:schemeClr val="accent2"/>
-      <a:schemeClr val="accent3"/>
-      <a:schemeClr val="accent4"/>
-      <a:schemeClr val="accent5"/>
-      <a:schemeClr val="accent6"/>
     </dgm:linClrLst>
     <dgm:effectClrLst/>
     <dgm:txLinClrLst/>
@@ -734,10 +662,6 @@
     </dgm:fillClrLst>
     <dgm:linClrLst meth="repeat">
       <a:schemeClr val="accent2"/>
-      <a:schemeClr val="accent3"/>
-      <a:schemeClr val="accent4"/>
-      <a:schemeClr val="accent5"/>
-      <a:schemeClr val="accent6"/>
     </dgm:linClrLst>
     <dgm:effectClrLst/>
     <dgm:txLinClrLst/>
@@ -749,46 +673,14 @@
   <dgm:styleLbl name="fgAccFollowNode1">
     <dgm:fillClrLst meth="repeat">
       <a:schemeClr val="accent2">
+        <a:alpha val="90000"/>
         <a:tint val="40000"/>
-        <a:alpha val="90000"/>
-      </a:schemeClr>
-      <a:schemeClr val="accent3">
-        <a:tint val="40000"/>
-        <a:alpha val="90000"/>
-      </a:schemeClr>
-      <a:schemeClr val="accent4">
-        <a:tint val="40000"/>
-        <a:alpha val="90000"/>
-      </a:schemeClr>
-      <a:schemeClr val="accent5">
-        <a:tint val="40000"/>
-        <a:alpha val="90000"/>
-      </a:schemeClr>
-      <a:schemeClr val="accent6">
-        <a:tint val="40000"/>
-        <a:alpha val="90000"/>
       </a:schemeClr>
     </dgm:fillClrLst>
     <dgm:linClrLst meth="repeat">
       <a:schemeClr val="accent2">
+        <a:alpha val="90000"/>
         <a:tint val="40000"/>
-        <a:alpha val="90000"/>
-      </a:schemeClr>
-      <a:schemeClr val="accent3">
-        <a:tint val="40000"/>
-        <a:alpha val="90000"/>
-      </a:schemeClr>
-      <a:schemeClr val="accent4">
-        <a:tint val="40000"/>
-        <a:alpha val="90000"/>
-      </a:schemeClr>
-      <a:schemeClr val="accent5">
-        <a:tint val="40000"/>
-        <a:alpha val="90000"/>
-      </a:schemeClr>
-      <a:schemeClr val="accent6">
-        <a:tint val="40000"/>
-        <a:alpha val="90000"/>
       </a:schemeClr>
     </dgm:linClrLst>
     <dgm:effectClrLst/>
@@ -801,46 +693,14 @@
   <dgm:styleLbl name="alignAccFollowNode1">
     <dgm:fillClrLst meth="repeat">
       <a:schemeClr val="accent2">
+        <a:alpha val="90000"/>
         <a:tint val="40000"/>
-        <a:alpha val="90000"/>
-      </a:schemeClr>
-      <a:schemeClr val="accent3">
-        <a:tint val="40000"/>
-        <a:alpha val="90000"/>
-      </a:schemeClr>
-      <a:schemeClr val="accent4">
-        <a:tint val="40000"/>
-        <a:alpha val="90000"/>
-      </a:schemeClr>
-      <a:schemeClr val="accent5">
-        <a:tint val="40000"/>
-        <a:alpha val="90000"/>
-      </a:schemeClr>
-      <a:schemeClr val="accent6">
-        <a:tint val="40000"/>
-        <a:alpha val="90000"/>
       </a:schemeClr>
     </dgm:fillClrLst>
     <dgm:linClrLst meth="repeat">
       <a:schemeClr val="accent2">
+        <a:alpha val="90000"/>
         <a:tint val="40000"/>
-        <a:alpha val="90000"/>
-      </a:schemeClr>
-      <a:schemeClr val="accent3">
-        <a:tint val="40000"/>
-        <a:alpha val="90000"/>
-      </a:schemeClr>
-      <a:schemeClr val="accent4">
-        <a:tint val="40000"/>
-        <a:alpha val="90000"/>
-      </a:schemeClr>
-      <a:schemeClr val="accent5">
-        <a:tint val="40000"/>
-        <a:alpha val="90000"/>
-      </a:schemeClr>
-      <a:schemeClr val="accent6">
-        <a:tint val="40000"/>
-        <a:alpha val="90000"/>
       </a:schemeClr>
     </dgm:linClrLst>
     <dgm:effectClrLst/>
@@ -853,46 +713,14 @@
   <dgm:styleLbl name="bgAccFollowNode1">
     <dgm:fillClrLst meth="repeat">
       <a:schemeClr val="accent2">
+        <a:alpha val="90000"/>
         <a:tint val="40000"/>
-        <a:alpha val="90000"/>
-      </a:schemeClr>
-      <a:schemeClr val="accent3">
-        <a:tint val="40000"/>
-        <a:alpha val="90000"/>
-      </a:schemeClr>
-      <a:schemeClr val="accent4">
-        <a:tint val="40000"/>
-        <a:alpha val="90000"/>
-      </a:schemeClr>
-      <a:schemeClr val="accent5">
-        <a:tint val="40000"/>
-        <a:alpha val="90000"/>
-      </a:schemeClr>
-      <a:schemeClr val="accent6">
-        <a:tint val="40000"/>
-        <a:alpha val="90000"/>
       </a:schemeClr>
     </dgm:fillClrLst>
     <dgm:linClrLst meth="repeat">
       <a:schemeClr val="accent2">
+        <a:alpha val="90000"/>
         <a:tint val="40000"/>
-        <a:alpha val="90000"/>
-      </a:schemeClr>
-      <a:schemeClr val="accent3">
-        <a:tint val="40000"/>
-        <a:alpha val="90000"/>
-      </a:schemeClr>
-      <a:schemeClr val="accent4">
-        <a:tint val="40000"/>
-        <a:alpha val="90000"/>
-      </a:schemeClr>
-      <a:schemeClr val="accent5">
-        <a:tint val="40000"/>
-        <a:alpha val="90000"/>
-      </a:schemeClr>
-      <a:schemeClr val="accent6">
-        <a:tint val="40000"/>
-        <a:alpha val="90000"/>
       </a:schemeClr>
     </dgm:linClrLst>
     <dgm:effectClrLst/>
@@ -908,8 +736,8 @@
         <a:alpha val="90000"/>
       </a:schemeClr>
     </dgm:fillClrLst>
-    <dgm:linClrLst>
-      <a:schemeClr val="accent1"/>
+    <dgm:linClrLst meth="repeat">
+      <a:schemeClr val="accent2"/>
     </dgm:linClrLst>
     <dgm:effectClrLst/>
     <dgm:txLinClrLst/>
@@ -924,7 +752,7 @@
         <a:alpha val="90000"/>
       </a:schemeClr>
     </dgm:fillClrLst>
-    <dgm:linClrLst>
+    <dgm:linClrLst meth="repeat">
       <a:schemeClr val="accent2"/>
     </dgm:linClrLst>
     <dgm:effectClrLst/>
@@ -940,8 +768,8 @@
         <a:alpha val="90000"/>
       </a:schemeClr>
     </dgm:fillClrLst>
-    <dgm:linClrLst>
-      <a:schemeClr val="accent3"/>
+    <dgm:linClrLst meth="repeat">
+      <a:schemeClr val="accent2"/>
     </dgm:linClrLst>
     <dgm:effectClrLst/>
     <dgm:txLinClrLst/>
@@ -956,8 +784,8 @@
         <a:alpha val="90000"/>
       </a:schemeClr>
     </dgm:fillClrLst>
-    <dgm:linClrLst>
-      <a:schemeClr val="accent4"/>
+    <dgm:linClrLst meth="repeat">
+      <a:schemeClr val="accent2"/>
     </dgm:linClrLst>
     <dgm:effectClrLst/>
     <dgm:txLinClrLst/>
@@ -973,7 +801,7 @@
       </a:schemeClr>
     </dgm:fillClrLst>
     <dgm:linClrLst meth="repeat">
-      <a:schemeClr val="dk1"/>
+      <a:schemeClr val="accent2"/>
     </dgm:linClrLst>
     <dgm:effectClrLst/>
     <dgm:txLinClrLst/>
@@ -985,11 +813,11 @@
   <dgm:styleLbl name="dkBgShp">
     <dgm:fillClrLst meth="repeat">
       <a:schemeClr val="accent2">
-        <a:shade val="90000"/>
+        <a:shade val="80000"/>
       </a:schemeClr>
     </dgm:fillClrLst>
     <dgm:linClrLst meth="repeat">
-      <a:schemeClr val="dk1"/>
+      <a:schemeClr val="accent2"/>
     </dgm:linClrLst>
     <dgm:effectClrLst/>
     <dgm:txLinClrLst/>
@@ -1000,7 +828,7 @@
   </dgm:styleLbl>
   <dgm:styleLbl name="trBgShp">
     <dgm:fillClrLst meth="repeat">
-      <a:schemeClr val="accent1">
+      <a:schemeClr val="accent2">
         <a:tint val="50000"/>
         <a:alpha val="40000"/>
       </a:schemeClr>
@@ -1018,7 +846,7 @@
   <dgm:styleLbl name="fgShp">
     <dgm:fillClrLst meth="repeat">
       <a:schemeClr val="accent2">
-        <a:tint val="40000"/>
+        <a:tint val="60000"/>
       </a:schemeClr>
     </dgm:fillClrLst>
     <dgm:linClrLst meth="repeat">
@@ -1056,7 +884,7 @@
 <dgm:dataModel xmlns:dgm="http://schemas.openxmlformats.org/drawingml/2006/diagram" xmlns:a="http://schemas.openxmlformats.org/drawingml/2006/main">
   <dgm:ptLst>
     <dgm:pt modelId="{9CC60296-2226-4ED4-ABF6-A10D529B1D53}" type="doc">
-      <dgm:prSet loTypeId="urn:microsoft.com/office/officeart/2005/8/layout/cycle2" loCatId="cycle" qsTypeId="urn:microsoft.com/office/officeart/2005/8/quickstyle/simple1" qsCatId="simple" csTypeId="urn:microsoft.com/office/officeart/2005/8/colors/colorful1" csCatId="colorful" phldr="1"/>
+      <dgm:prSet loTypeId="urn:microsoft.com/office/officeart/2005/8/layout/cycle2" loCatId="cycle" qsTypeId="urn:microsoft.com/office/officeart/2005/8/quickstyle/simple1" qsCatId="simple" csTypeId="urn:microsoft.com/office/officeart/2005/8/colors/accent2_2" csCatId="accent2" phldr="1"/>
       <dgm:spPr/>
       <dgm:t>
         <a:bodyPr/>
@@ -1086,6 +914,11 @@
           </a:r>
         </a:p>
       </dgm:t>
+      <dgm:extLst>
+        <a:ext uri="{E40237B7-FDA0-4F09-8148-C483321AD2D9}">
+          <dgm14:cNvPr xmlns:dgm14="http://schemas.microsoft.com/office/drawing/2010/diagram" id="0" name="" descr="FETCH&#10;the instruction and any data from main memory&#10;DECODE &#10;the instruction (i.e., convert the instruction into a language the CPU understands)&#10;EXECUTE &#10;the instruction (i.e., complete the instruction)&#10;"/>
+        </a:ext>
+      </dgm:extLst>
     </dgm:pt>
     <dgm:pt modelId="{239D0E50-56A5-468A-8C02-4BE7FD8E6F80}" type="parTrans" cxnId="{578AC273-B064-4322-9F96-4607383BC9D3}">
       <dgm:prSet/>
@@ -1133,6 +966,11 @@
           </a:r>
         </a:p>
       </dgm:t>
+      <dgm:extLst>
+        <a:ext uri="{E40237B7-FDA0-4F09-8148-C483321AD2D9}">
+          <dgm14:cNvPr xmlns:dgm14="http://schemas.microsoft.com/office/drawing/2010/diagram" id="0" name="" descr="FETCH&#10;the instruction and any data from main memory&#10;DECODE &#10;the instruction (i.e., convert the instruction into a language the CPU understands)&#10;EXECUTE &#10;the instruction (i.e., complete the instruction)&#10;"/>
+        </a:ext>
+      </dgm:extLst>
     </dgm:pt>
     <dgm:pt modelId="{7EBA42EA-C0C0-4343-B5A9-C096CEEDB2D9}" type="parTrans" cxnId="{7E907F80-627F-48A9-8613-4FEC948C2CA8}">
       <dgm:prSet/>
@@ -1180,6 +1018,11 @@
           </a:r>
         </a:p>
       </dgm:t>
+      <dgm:extLst>
+        <a:ext uri="{E40237B7-FDA0-4F09-8148-C483321AD2D9}">
+          <dgm14:cNvPr xmlns:dgm14="http://schemas.microsoft.com/office/drawing/2010/diagram" id="0" name="" descr="FETCH&#10;the instruction and any data from main memory&#10;DECODE &#10;the instruction (i.e., convert the instruction into a language the CPU understands)&#10;EXECUTE &#10;the instruction (i.e., complete the instruction)&#10;"/>
+        </a:ext>
+      </dgm:extLst>
     </dgm:pt>
     <dgm:pt modelId="{22D06E63-86BC-4A89-B2BE-A112F16F67E4}" type="parTrans" cxnId="{4EF82EBA-2BA9-4F74-98AB-780E27221DEB}">
       <dgm:prSet/>
@@ -1406,6 +1249,7 @@
         </a:prstGeom>
         <a:solidFill>
           <a:schemeClr val="accent2">
+            <a:tint val="60000"/>
             <a:hueOff val="0"/>
             <a:satOff val="0"/>
             <a:lumOff val="0"/>
@@ -1471,7 +1315,7 @@
           <a:avLst/>
         </a:prstGeom>
         <a:solidFill>
-          <a:schemeClr val="accent3">
+          <a:schemeClr val="accent2">
             <a:hueOff val="0"/>
             <a:satOff val="0"/>
             <a:lumOff val="0"/>
@@ -1563,7 +1407,8 @@
           </a:avLst>
         </a:prstGeom>
         <a:solidFill>
-          <a:schemeClr val="accent3">
+          <a:schemeClr val="accent2">
+            <a:tint val="60000"/>
             <a:hueOff val="0"/>
             <a:satOff val="0"/>
             <a:lumOff val="0"/>
@@ -1629,7 +1474,7 @@
           <a:avLst/>
         </a:prstGeom>
         <a:solidFill>
-          <a:schemeClr val="accent4">
+          <a:schemeClr val="accent2">
             <a:hueOff val="0"/>
             <a:satOff val="0"/>
             <a:lumOff val="0"/>
@@ -1721,7 +1566,8 @@
           </a:avLst>
         </a:prstGeom>
         <a:solidFill>
-          <a:schemeClr val="accent4">
+          <a:schemeClr val="accent2">
+            <a:tint val="60000"/>
             <a:hueOff val="0"/>
             <a:satOff val="0"/>
             <a:lumOff val="0"/>
@@ -3119,7 +2965,7 @@
           <a:p>
             <a:fld id="{235382CB-D6B4-48E5-AFFD-4242D787BD27}" type="datetime2">
               <a:rPr lang="en-US" smtClean="0"/>
-              <a:t>Friday, April 3, 2026</a:t>
+              <a:t>Tuesday, April 7, 2026</a:t>
             </a:fld>
             <a:endParaRPr lang="en-US"/>
           </a:p>
@@ -3303,7 +3149,7 @@
           <a:p>
             <a:fld id="{F76BFB3A-AF09-4935-935F-AADA8F949CAB}" type="datetime2">
               <a:rPr lang="en-US" smtClean="0"/>
-              <a:t>Friday, April 3, 2026</a:t>
+              <a:t>Tuesday, April 7, 2026</a:t>
             </a:fld>
             <a:endParaRPr lang="en-US"/>
           </a:p>
@@ -9102,7 +8948,7 @@
       </p:sp>
       <p:graphicFrame>
         <p:nvGraphicFramePr>
-          <p:cNvPr id="7" name="Content Placeholder 6">
+          <p:cNvPr id="7" name="Content Placeholder 6" descr="FETCH&#10;the instruction and any data from main memory&#10;DECODE &#10;the instruction (i.e., convert the instruction into a language the CPU understands)&#10;EXECUTE &#10;the instruction (i.e., complete the instruction)&#10;">
             <a:extLst>
               <a:ext uri="{FF2B5EF4-FFF2-40B4-BE49-F238E27FC236}">
                 <a16:creationId xmlns:a16="http://schemas.microsoft.com/office/drawing/2014/main" id="{A436436B-DBB3-29FE-E7F0-18348D677EA6}"/>
@@ -9116,7 +8962,7 @@
             <p:ph sz="half" idx="13"/>
             <p:extLst>
               <p:ext uri="{D42A27DB-BD31-4B8C-83A1-F6EECF244321}">
-                <p14:modId xmlns:p14="http://schemas.microsoft.com/office/powerpoint/2010/main" val="2893179953"/>
+                <p14:modId xmlns:p14="http://schemas.microsoft.com/office/powerpoint/2010/main" val="77453956"/>
               </p:ext>
             </p:extLst>
           </p:nvPr>

</xml_diff>